<commit_message>
Pasada de riqueza visual del pptx + plantilla docx de marca
pptx de MT25: 6 slides que eran solo título+bullets ahora usan cards/
chips/stats del kit compartido (mismo dato, más jerarquía visual) —
llevó la densidad de shapes de 3.85 a 5.23 por slide, más cerca del
7.18 de referencia de mt10. De paso corrige un bug real de word-wrap
en stat_card a nivel de kit compartido (pptx_kit.py), no solo en el
archivo de mt25.

guion.docx: reemplaza el .docx sin estilo (template default de pandoc)
por una plantilla de referencia de marca (design-system/components/
docx-reference.docx + docx_kit.py) con los mismos tokens de color/
tipografía que el pptx — headings con acento de marca, blockquotes
tratados como callout, tabla con header oscuro shadeado celda por
celda (Pages/Word ignoran el conditional formatting de tabla del
estilo solo).

Co-Authored-By: Claude Sonnet 5 <noreply@anthropic.com>
</commit_message>
<xml_diff>
--- a/materias/mt25-estrategias-negocios-internet/business-plan-coto/entregable/presentacion/business-plan-coto.pptx
+++ b/materias/mt25-estrategias-negocios-internet/business-plan-coto/entregable/presentacion/business-plan-coto.pptx
@@ -4757,14 +4757,94 @@
       </p:sp>
       <p:sp>
         <p:nvSpPr>
-          <p:cNvPr id="5" name="TextBox 4"/>
+          <p:cNvPr id="5" name="Rounded Rectangle 4"/>
+          <p:cNvSpPr/>
+          <p:nvPr/>
+        </p:nvSpPr>
+        <p:spPr>
+          <a:xfrm>
+            <a:off x="548640" y="1920240"/>
+            <a:ext cx="5120640" cy="3291840"/>
+          </a:xfrm>
+          <a:prstGeom prst="roundRect">
+            <a:avLst>
+              <a:gd name="adj" fmla="val 6000"/>
+            </a:avLst>
+          </a:prstGeom>
+          <a:solidFill>
+            <a:srgbClr val="FFFFFF"/>
+          </a:solidFill>
+          <a:ln>
+            <a:noFill/>
+          </a:ln>
+          <a:effectLst/>
+        </p:spPr>
+        <p:style>
+          <a:lnRef idx="1">
+            <a:schemeClr val="accent1"/>
+          </a:lnRef>
+          <a:fillRef idx="3">
+            <a:schemeClr val="accent1"/>
+          </a:fillRef>
+          <a:effectRef idx="2">
+            <a:schemeClr val="accent1"/>
+          </a:effectRef>
+          <a:fontRef idx="minor">
+            <a:schemeClr val="lt1"/>
+          </a:fontRef>
+        </p:style>
+        <p:txBody>
+          <a:bodyPr rtlCol="0" anchor="ctr"/>
+          <a:lstStyle/>
+          <a:p>
+            <a:pPr algn="ctr"/>
+          </a:p>
+        </p:txBody>
+      </p:sp>
+      <p:sp>
+        <p:nvSpPr>
+          <p:cNvPr id="6" name="TextBox 5"/>
           <p:cNvSpPr txBox="1"/>
           <p:nvPr/>
         </p:nvSpPr>
         <p:spPr>
           <a:xfrm>
-            <a:off x="548640" y="1920240"/>
-            <a:ext cx="5120640" cy="1188720"/>
+            <a:off x="868680" y="2194560"/>
+            <a:ext cx="4526279" cy="457200"/>
+          </a:xfrm>
+          <a:prstGeom prst="rect">
+            <a:avLst/>
+          </a:prstGeom>
+          <a:noFill/>
+        </p:spPr>
+        <p:txBody>
+          <a:bodyPr wrap="none">
+            <a:spAutoFit/>
+          </a:bodyPr>
+          <a:lstStyle/>
+          <a:p>
+            <a:r>
+              <a:rPr sz="3400" b="1" i="0">
+                <a:solidFill>
+                  <a:srgbClr val="502BD8"/>
+                </a:solidFill>
+                <a:latin typeface="Inter"/>
+              </a:rPr>
+              <a:t>USD 900.000</a:t>
+            </a:r>
+          </a:p>
+        </p:txBody>
+      </p:sp>
+      <p:sp>
+        <p:nvSpPr>
+          <p:cNvPr id="7" name="TextBox 6"/>
+          <p:cNvSpPr txBox="1"/>
+          <p:nvPr/>
+        </p:nvSpPr>
+        <p:spPr>
+          <a:xfrm>
+            <a:off x="868680" y="2724912"/>
+            <a:ext cx="4526279" cy="624535"/>
           </a:xfrm>
           <a:prstGeom prst="rect">
             <a:avLst/>
@@ -4778,72 +4858,38 @@
           <a:lstStyle/>
           <a:p>
             <a:r>
-              <a:rPr sz="4000" b="1" i="0">
-                <a:solidFill>
-                  <a:srgbClr val="502BD8"/>
-                </a:solidFill>
-                <a:latin typeface="Inter"/>
-              </a:rPr>
-              <a:t>USD 900.000</a:t>
-            </a:r>
-          </a:p>
-        </p:txBody>
-      </p:sp>
-      <p:sp>
-        <p:nvSpPr>
-          <p:cNvPr id="6" name="TextBox 5"/>
+              <a:rPr sz="1300" b="0" i="0">
+                <a:solidFill>
+                  <a:srgbClr val="6E6E6E"/>
+                </a:solidFill>
+                <a:latin typeface="Inter"/>
+              </a:rPr>
+              <a:t>CAPEX inicial (Fase 0-1) — partnership</a:t>
+            </a:r>
+          </a:p>
+          <a:p>
+            <a:r>
+              <a:rPr sz="1300" b="0" i="0">
+                <a:solidFill>
+                  <a:srgbClr val="6E6E6E"/>
+                </a:solidFill>
+                <a:latin typeface="Inter"/>
+              </a:rPr>
+              <a:t>con PSP/BaaS, sin infra. bancaria propia</a:t>
+            </a:r>
+          </a:p>
+        </p:txBody>
+      </p:sp>
+      <p:sp>
+        <p:nvSpPr>
+          <p:cNvPr id="8" name="TextBox 7"/>
           <p:cNvSpPr txBox="1"/>
           <p:nvPr/>
         </p:nvSpPr>
         <p:spPr>
           <a:xfrm>
-            <a:off x="594360" y="2971800"/>
-            <a:ext cx="5029200" cy="822960"/>
-          </a:xfrm>
-          <a:prstGeom prst="rect">
-            <a:avLst/>
-          </a:prstGeom>
-          <a:noFill/>
-        </p:spPr>
-        <p:txBody>
-          <a:bodyPr wrap="square">
-            <a:spAutoFit/>
-          </a:bodyPr>
-          <a:lstStyle/>
-          <a:p>
-            <a:r>
-              <a:rPr sz="1550" b="0" i="0">
-                <a:solidFill>
-                  <a:srgbClr val="6E6E6E"/>
-                </a:solidFill>
-                <a:latin typeface="Inter"/>
-              </a:rPr>
-              <a:t>CAPEX inicial (Fase 0-1) — partnership</a:t>
-            </a:r>
-          </a:p>
-          <a:p>
-            <a:r>
-              <a:rPr sz="1550" b="0" i="0">
-                <a:solidFill>
-                  <a:srgbClr val="6E6E6E"/>
-                </a:solidFill>
-                <a:latin typeface="Inter"/>
-              </a:rPr>
-              <a:t>con PSP/BaaS, sin infra. bancaria propia</a:t>
-            </a:r>
-          </a:p>
-        </p:txBody>
-      </p:sp>
-      <p:sp>
-        <p:nvSpPr>
-          <p:cNvPr id="7" name="TextBox 6"/>
-          <p:cNvSpPr txBox="1"/>
-          <p:nvPr/>
-        </p:nvSpPr>
-        <p:spPr>
-          <a:xfrm>
-            <a:off x="6035040" y="1920240"/>
-            <a:ext cx="5394960" cy="2011680"/>
+            <a:off x="868680" y="3532327"/>
+            <a:ext cx="4526279" cy="1542592"/>
           </a:xfrm>
           <a:prstGeom prst="rect">
             <a:avLst/>
@@ -4862,7 +4908,7 @@
               </a:spcAft>
             </a:pPr>
             <a:r>
-              <a:rPr sz="1250" b="1" i="0">
+              <a:rPr sz="1300" b="1" i="0">
                 <a:solidFill>
                   <a:srgbClr val="502BD8"/>
                 </a:solidFill>
@@ -4871,13 +4917,13 @@
               <a:t>—  </a:t>
             </a:r>
             <a:r>
-              <a:rPr sz="1250" b="1" i="0">
+              <a:rPr sz="1300" b="0" i="0">
                 <a:solidFill>
                   <a:srgbClr val="222222"/>
                 </a:solidFill>
                 <a:latin typeface="Inter"/>
               </a:rPr>
-              <a:t>OPEX: equipo de 8-12 personas + incentivos de lanzamiento 3-5% del GMV objetivo (por analogía con reintegros de MP 10-25% / MODO 20-30%).</a:t>
+              <a:t>Plataforma (app+backend+QR) — USD 550.000</a:t>
             </a:r>
           </a:p>
           <a:p>
@@ -4887,7 +4933,7 @@
               </a:spcAft>
             </a:pPr>
             <a:r>
-              <a:rPr sz="1250" b="1" i="0">
+              <a:rPr sz="1300" b="1" i="0">
                 <a:solidFill>
                   <a:srgbClr val="502BD8"/>
                 </a:solidFill>
@@ -4896,13 +4942,13 @@
               <a:t>—  </a:t>
             </a:r>
             <a:r>
-              <a:rPr sz="1250" b="1" i="0">
+              <a:rPr sz="1300" b="0" i="0">
                 <a:solidFill>
                   <a:srgbClr val="222222"/>
                 </a:solidFill>
                 <a:latin typeface="Inter"/>
               </a:rPr>
-              <a:t>GMV capturado ≠ ingreso incremental: 20% se fija como fracción genuinamente incremental (extremo conservador de 20-30%).</a:t>
+              <a:t>Integración con COTO (POS, CRM) — USD 200.000</a:t>
             </a:r>
           </a:p>
           <a:p>
@@ -4912,6 +4958,54 @@
               </a:spcAft>
             </a:pPr>
             <a:r>
+              <a:rPr sz="1300" b="1" i="0">
+                <a:solidFill>
+                  <a:srgbClr val="502BD8"/>
+                </a:solidFill>
+                <a:latin typeface="Inter"/>
+              </a:rPr>
+              <a:t>—  </a:t>
+            </a:r>
+            <a:r>
+              <a:rPr sz="1300" b="0" i="0">
+                <a:solidFill>
+                  <a:srgbClr val="222222"/>
+                </a:solidFill>
+                <a:latin typeface="Inter"/>
+              </a:rPr>
+              <a:t>Compliance / KYC-AML — USD 150.000</a:t>
+            </a:r>
+          </a:p>
+        </p:txBody>
+      </p:sp>
+      <p:sp>
+        <p:nvSpPr>
+          <p:cNvPr id="9" name="TextBox 8"/>
+          <p:cNvSpPr txBox="1"/>
+          <p:nvPr/>
+        </p:nvSpPr>
+        <p:spPr>
+          <a:xfrm>
+            <a:off x="6035040" y="1920240"/>
+            <a:ext cx="5394960" cy="2377440"/>
+          </a:xfrm>
+          <a:prstGeom prst="rect">
+            <a:avLst/>
+          </a:prstGeom>
+          <a:noFill/>
+        </p:spPr>
+        <p:txBody>
+          <a:bodyPr wrap="square">
+            <a:spAutoFit/>
+          </a:bodyPr>
+          <a:lstStyle/>
+          <a:p>
+            <a:pPr>
+              <a:spcAft>
+                <a:spcPts val="800"/>
+              </a:spcAft>
+            </a:pPr>
+            <a:r>
               <a:rPr sz="1250" b="1" i="0">
                 <a:solidFill>
                   <a:srgbClr val="502BD8"/>
@@ -4927,6 +5021,56 @@
                 </a:solidFill>
                 <a:latin typeface="Inter"/>
               </a:rPr>
+              <a:t>OPEX: equipo de 8-12 personas + incentivos de lanzamiento 3-5% del GMV objetivo (por analogía con reintegros de MP 10-25% / MODO 20-30%).</a:t>
+            </a:r>
+          </a:p>
+          <a:p>
+            <a:pPr>
+              <a:spcAft>
+                <a:spcPts val="800"/>
+              </a:spcAft>
+            </a:pPr>
+            <a:r>
+              <a:rPr sz="1250" b="1" i="0">
+                <a:solidFill>
+                  <a:srgbClr val="502BD8"/>
+                </a:solidFill>
+                <a:latin typeface="Inter"/>
+              </a:rPr>
+              <a:t>—  </a:t>
+            </a:r>
+            <a:r>
+              <a:rPr sz="1250" b="1" i="0">
+                <a:solidFill>
+                  <a:srgbClr val="222222"/>
+                </a:solidFill>
+                <a:latin typeface="Inter"/>
+              </a:rPr>
+              <a:t>GMV capturado ≠ ingreso incremental: 20% se fija como fracción genuinamente incremental (extremo conservador de 20-30%).</a:t>
+            </a:r>
+          </a:p>
+          <a:p>
+            <a:pPr>
+              <a:spcAft>
+                <a:spcPts val="800"/>
+              </a:spcAft>
+            </a:pPr>
+            <a:r>
+              <a:rPr sz="1250" b="1" i="0">
+                <a:solidFill>
+                  <a:srgbClr val="502BD8"/>
+                </a:solidFill>
+                <a:latin typeface="Inter"/>
+              </a:rPr>
+              <a:t>—  </a:t>
+            </a:r>
+            <a:r>
+              <a:rPr sz="1250" b="1" i="0">
+                <a:solidFill>
+                  <a:srgbClr val="222222"/>
+                </a:solidFill>
+                <a:latin typeface="Inter"/>
+              </a:rPr>
               <a:t>Margen bruto retail asociado: 22% (supuesto del equipo, sin benchmark local).</a:t>
             </a:r>
           </a:p>
@@ -4934,14 +5078,14 @@
       </p:sp>
       <p:sp>
         <p:nvSpPr>
-          <p:cNvPr id="8" name="Rounded Rectangle 7"/>
+          <p:cNvPr id="10" name="Rounded Rectangle 9"/>
           <p:cNvSpPr/>
           <p:nvPr/>
         </p:nvSpPr>
         <p:spPr>
           <a:xfrm>
-            <a:off x="548640" y="5257800"/>
-            <a:ext cx="10881360" cy="822960"/>
+            <a:off x="548640" y="5486400"/>
+            <a:ext cx="10881360" cy="640080"/>
           </a:xfrm>
           <a:prstGeom prst="roundRect">
             <a:avLst>
@@ -4989,7 +5133,7 @@
       </p:sp>
       <p:sp>
         <p:nvSpPr>
-          <p:cNvPr id="9" name="TextBox 8"/>
+          <p:cNvPr id="11" name="TextBox 10"/>
           <p:cNvSpPr txBox="1"/>
           <p:nvPr/>
         </p:nvSpPr>
@@ -5023,7 +5167,7 @@
       </p:sp>
       <p:sp>
         <p:nvSpPr>
-          <p:cNvPr id="10" name="TextBox 9"/>
+          <p:cNvPr id="12" name="TextBox 11"/>
           <p:cNvSpPr txBox="1"/>
           <p:nvPr/>
         </p:nvSpPr>
@@ -6704,14 +6848,115 @@
       </p:sp>
       <p:sp>
         <p:nvSpPr>
-          <p:cNvPr id="5" name="TextBox 4"/>
+          <p:cNvPr id="5" name="Rounded Rectangle 4"/>
+          <p:cNvSpPr/>
+          <p:nvPr/>
+        </p:nvSpPr>
+        <p:spPr>
+          <a:xfrm>
+            <a:off x="548640" y="2103120"/>
+            <a:ext cx="10881360" cy="1463040"/>
+          </a:xfrm>
+          <a:prstGeom prst="roundRect">
+            <a:avLst>
+              <a:gd name="adj" fmla="val 6000"/>
+            </a:avLst>
+          </a:prstGeom>
+          <a:solidFill>
+            <a:srgbClr val="FFFFFF"/>
+          </a:solidFill>
+          <a:ln>
+            <a:noFill/>
+          </a:ln>
+          <a:effectLst/>
+        </p:spPr>
+        <p:style>
+          <a:lnRef idx="1">
+            <a:schemeClr val="accent1"/>
+          </a:lnRef>
+          <a:fillRef idx="3">
+            <a:schemeClr val="accent1"/>
+          </a:fillRef>
+          <a:effectRef idx="2">
+            <a:schemeClr val="accent1"/>
+          </a:effectRef>
+          <a:fontRef idx="minor">
+            <a:schemeClr val="lt1"/>
+          </a:fontRef>
+        </p:style>
+        <p:txBody>
+          <a:bodyPr rtlCol="0" anchor="ctr"/>
+          <a:lstStyle/>
+          <a:p>
+            <a:pPr algn="ctr"/>
+          </a:p>
+        </p:txBody>
+      </p:sp>
+      <p:sp>
+        <p:nvSpPr>
+          <p:cNvPr id="6" name="Rounded Rectangle 5"/>
+          <p:cNvSpPr/>
+          <p:nvPr/>
+        </p:nvSpPr>
+        <p:spPr>
+          <a:xfrm>
+            <a:off x="777240" y="2331720"/>
+            <a:ext cx="2926080" cy="347472"/>
+          </a:xfrm>
+          <a:prstGeom prst="roundRect">
+            <a:avLst>
+              <a:gd name="adj" fmla="val 50000"/>
+            </a:avLst>
+          </a:prstGeom>
+          <a:solidFill>
+            <a:srgbClr val="EDEDED"/>
+          </a:solidFill>
+          <a:ln>
+            <a:noFill/>
+          </a:ln>
+          <a:effectLst/>
+        </p:spPr>
+        <p:style>
+          <a:lnRef idx="1">
+            <a:schemeClr val="accent1"/>
+          </a:lnRef>
+          <a:fillRef idx="3">
+            <a:schemeClr val="accent1"/>
+          </a:fillRef>
+          <a:effectRef idx="2">
+            <a:schemeClr val="accent1"/>
+          </a:effectRef>
+          <a:fontRef idx="minor">
+            <a:schemeClr val="lt1"/>
+          </a:fontRef>
+        </p:style>
+        <p:txBody>
+          <a:bodyPr rtlCol="0" anchor="ctr" wrap="square" lIns="73152" rIns="73152"/>
+          <a:lstStyle/>
+          <a:p>
+            <a:pPr algn="ctr"/>
+            <a:r>
+              <a:rPr sz="1100" b="0" i="0">
+                <a:solidFill>
+                  <a:srgbClr val="6E6E6E"/>
+                </a:solidFill>
+                <a:latin typeface="Inter"/>
+              </a:rPr>
+              <a:t>PENDIENTE</a:t>
+            </a:r>
+          </a:p>
+        </p:txBody>
+      </p:sp>
+      <p:sp>
+        <p:nvSpPr>
+          <p:cNvPr id="7" name="TextBox 6"/>
           <p:cNvSpPr txBox="1"/>
           <p:nvPr/>
         </p:nvSpPr>
         <p:spPr>
           <a:xfrm>
-            <a:off x="548640" y="2103120"/>
-            <a:ext cx="10881360" cy="822960"/>
+            <a:off x="777240" y="2816352"/>
+            <a:ext cx="10424160" cy="566928"/>
           </a:xfrm>
           <a:prstGeom prst="rect">
             <a:avLst/>
@@ -6725,7 +6970,7 @@
           <a:lstStyle/>
           <a:p>
             <a:r>
-              <a:rPr sz="1800" b="0" i="0">
+              <a:rPr sz="1300" b="0" i="0">
                 <a:solidFill>
                   <a:srgbClr val="222222"/>
                 </a:solidFill>
@@ -6738,7 +6983,62 @@
       </p:sp>
       <p:sp>
         <p:nvSpPr>
-          <p:cNvPr id="6" name="TextBox 5"/>
+          <p:cNvPr id="8" name="Rounded Rectangle 7"/>
+          <p:cNvSpPr/>
+          <p:nvPr/>
+        </p:nvSpPr>
+        <p:spPr>
+          <a:xfrm>
+            <a:off x="548640" y="3886200"/>
+            <a:ext cx="10881360" cy="822960"/>
+          </a:xfrm>
+          <a:prstGeom prst="roundRect">
+            <a:avLst>
+              <a:gd name="adj" fmla="val 10000"/>
+            </a:avLst>
+          </a:prstGeom>
+          <a:solidFill>
+            <a:srgbClr val="ECE7FA"/>
+          </a:solidFill>
+          <a:ln>
+            <a:noFill/>
+          </a:ln>
+          <a:effectLst/>
+        </p:spPr>
+        <p:style>
+          <a:lnRef idx="1">
+            <a:schemeClr val="accent1"/>
+          </a:lnRef>
+          <a:fillRef idx="3">
+            <a:schemeClr val="accent1"/>
+          </a:fillRef>
+          <a:effectRef idx="2">
+            <a:schemeClr val="accent1"/>
+          </a:effectRef>
+          <a:fontRef idx="minor">
+            <a:schemeClr val="lt1"/>
+          </a:fontRef>
+        </p:style>
+        <p:txBody>
+          <a:bodyPr rtlCol="0" anchor="ctr" wrap="square" lIns="228600" rIns="228600"/>
+          <a:lstStyle/>
+          <a:p>
+            <a:pPr algn="ctr"/>
+            <a:r>
+              <a:rPr sz="1250" b="0" i="1">
+                <a:solidFill>
+                  <a:srgbClr val="222222"/>
+                </a:solidFill>
+                <a:latin typeface="Inter"/>
+              </a:rPr>
+              <a:t>El equipo debe completar esta sección con los datos reales de cada integrante antes de la entrega — no se inventan nombres ni backgrounds.</a:t>
+            </a:r>
+          </a:p>
+        </p:txBody>
+      </p:sp>
+      <p:sp>
+        <p:nvSpPr>
+          <p:cNvPr id="9" name="TextBox 8"/>
           <p:cNvSpPr txBox="1"/>
           <p:nvPr/>
         </p:nvSpPr>
@@ -6772,7 +7072,7 @@
       </p:sp>
       <p:sp>
         <p:nvSpPr>
-          <p:cNvPr id="7" name="TextBox 6"/>
+          <p:cNvPr id="10" name="TextBox 9"/>
           <p:cNvSpPr txBox="1"/>
           <p:nvPr/>
         </p:nvSpPr>
@@ -6976,8 +7276,8 @@
         </p:nvSpPr>
         <p:spPr>
           <a:xfrm>
-            <a:off x="548640" y="6510528"/>
-            <a:ext cx="8686800" cy="274320"/>
+            <a:off x="548640" y="4617720"/>
+            <a:ext cx="10881360" cy="320040"/>
           </a:xfrm>
           <a:prstGeom prst="rect">
             <a:avLst/>
@@ -6991,6 +7291,150 @@
           <a:lstStyle/>
           <a:p>
             <a:r>
+              <a:rPr sz="1200" b="1" i="0">
+                <a:solidFill>
+                  <a:srgbClr val="6E6E6E"/>
+                </a:solidFill>
+                <a:latin typeface="Inter"/>
+              </a:rPr>
+              <a:t>HOY, ESA RELACIÓN LA CONSTRUYEN</a:t>
+            </a:r>
+          </a:p>
+        </p:txBody>
+      </p:sp>
+      <p:sp>
+        <p:nvSpPr>
+          <p:cNvPr id="7" name="Rounded Rectangle 6"/>
+          <p:cNvSpPr/>
+          <p:nvPr/>
+        </p:nvSpPr>
+        <p:spPr>
+          <a:xfrm>
+            <a:off x="548640" y="4983480"/>
+            <a:ext cx="2194560" cy="384048"/>
+          </a:xfrm>
+          <a:prstGeom prst="roundRect">
+            <a:avLst>
+              <a:gd name="adj" fmla="val 50000"/>
+            </a:avLst>
+          </a:prstGeom>
+          <a:solidFill>
+            <a:srgbClr val="EDEDED"/>
+          </a:solidFill>
+          <a:ln>
+            <a:noFill/>
+          </a:ln>
+          <a:effectLst/>
+        </p:spPr>
+        <p:style>
+          <a:lnRef idx="1">
+            <a:schemeClr val="accent1"/>
+          </a:lnRef>
+          <a:fillRef idx="3">
+            <a:schemeClr val="accent1"/>
+          </a:fillRef>
+          <a:effectRef idx="2">
+            <a:schemeClr val="accent1"/>
+          </a:effectRef>
+          <a:fontRef idx="minor">
+            <a:schemeClr val="lt1"/>
+          </a:fontRef>
+        </p:style>
+        <p:txBody>
+          <a:bodyPr rtlCol="0" anchor="ctr" wrap="square" lIns="73152" rIns="73152"/>
+          <a:lstStyle/>
+          <a:p>
+            <a:pPr algn="ctr"/>
+            <a:r>
+              <a:rPr sz="1100" b="0" i="0">
+                <a:solidFill>
+                  <a:srgbClr val="6E6E6E"/>
+                </a:solidFill>
+                <a:latin typeface="Inter"/>
+              </a:rPr>
+              <a:t>Mercado Pago</a:t>
+            </a:r>
+          </a:p>
+        </p:txBody>
+      </p:sp>
+      <p:sp>
+        <p:nvSpPr>
+          <p:cNvPr id="8" name="Rounded Rectangle 7"/>
+          <p:cNvSpPr/>
+          <p:nvPr/>
+        </p:nvSpPr>
+        <p:spPr>
+          <a:xfrm>
+            <a:off x="2926080" y="4983480"/>
+            <a:ext cx="1463040" cy="384048"/>
+          </a:xfrm>
+          <a:prstGeom prst="roundRect">
+            <a:avLst>
+              <a:gd name="adj" fmla="val 50000"/>
+            </a:avLst>
+          </a:prstGeom>
+          <a:solidFill>
+            <a:srgbClr val="EDEDED"/>
+          </a:solidFill>
+          <a:ln>
+            <a:noFill/>
+          </a:ln>
+          <a:effectLst/>
+        </p:spPr>
+        <p:style>
+          <a:lnRef idx="1">
+            <a:schemeClr val="accent1"/>
+          </a:lnRef>
+          <a:fillRef idx="3">
+            <a:schemeClr val="accent1"/>
+          </a:fillRef>
+          <a:effectRef idx="2">
+            <a:schemeClr val="accent1"/>
+          </a:effectRef>
+          <a:fontRef idx="minor">
+            <a:schemeClr val="lt1"/>
+          </a:fontRef>
+        </p:style>
+        <p:txBody>
+          <a:bodyPr rtlCol="0" anchor="ctr" wrap="square" lIns="73152" rIns="73152"/>
+          <a:lstStyle/>
+          <a:p>
+            <a:pPr algn="ctr"/>
+            <a:r>
+              <a:rPr sz="1100" b="0" i="0">
+                <a:solidFill>
+                  <a:srgbClr val="6E6E6E"/>
+                </a:solidFill>
+                <a:latin typeface="Inter"/>
+              </a:rPr>
+              <a:t>MODO</a:t>
+            </a:r>
+          </a:p>
+        </p:txBody>
+      </p:sp>
+      <p:sp>
+        <p:nvSpPr>
+          <p:cNvPr id="9" name="TextBox 8"/>
+          <p:cNvSpPr txBox="1"/>
+          <p:nvPr/>
+        </p:nvSpPr>
+        <p:spPr>
+          <a:xfrm>
+            <a:off x="548640" y="6510528"/>
+            <a:ext cx="8686800" cy="274320"/>
+          </a:xfrm>
+          <a:prstGeom prst="rect">
+            <a:avLst/>
+          </a:prstGeom>
+          <a:noFill/>
+        </p:spPr>
+        <p:txBody>
+          <a:bodyPr wrap="square">
+            <a:spAutoFit/>
+          </a:bodyPr>
+          <a:lstStyle/>
+          <a:p>
+            <a:r>
               <a:rPr sz="900" b="0" i="0">
                 <a:solidFill>
                   <a:srgbClr val="6E6E6E"/>
@@ -7004,7 +7448,7 @@
       </p:sp>
       <p:sp>
         <p:nvSpPr>
-          <p:cNvPr id="7" name="TextBox 6"/>
+          <p:cNvPr id="10" name="TextBox 9"/>
           <p:cNvSpPr txBox="1"/>
           <p:nvPr/>
         </p:nvSpPr>
@@ -7175,7 +7619,97 @@
         <p:spPr>
           <a:xfrm>
             <a:off x="548640" y="1874519"/>
-            <a:ext cx="10881360" cy="2834640"/>
+            <a:ext cx="3657600" cy="1188720"/>
+          </a:xfrm>
+          <a:prstGeom prst="rect">
+            <a:avLst/>
+          </a:prstGeom>
+          <a:noFill/>
+        </p:spPr>
+        <p:txBody>
+          <a:bodyPr wrap="square">
+            <a:spAutoFit/>
+          </a:bodyPr>
+          <a:lstStyle/>
+          <a:p>
+            <a:r>
+              <a:rPr sz="4000" b="1" i="0">
+                <a:solidFill>
+                  <a:srgbClr val="502BD8"/>
+                </a:solidFill>
+                <a:latin typeface="Inter"/>
+              </a:rPr>
+              <a:t>20-30%</a:t>
+            </a:r>
+          </a:p>
+        </p:txBody>
+      </p:sp>
+      <p:sp>
+        <p:nvSpPr>
+          <p:cNvPr id="6" name="TextBox 5"/>
+          <p:cNvSpPr txBox="1"/>
+          <p:nvPr/>
+        </p:nvSpPr>
+        <p:spPr>
+          <a:xfrm>
+            <a:off x="594360" y="2926079"/>
+            <a:ext cx="3566160" cy="822960"/>
+          </a:xfrm>
+          <a:prstGeom prst="rect">
+            <a:avLst/>
+          </a:prstGeom>
+          <a:noFill/>
+        </p:spPr>
+        <p:txBody>
+          <a:bodyPr wrap="square">
+            <a:spAutoFit/>
+          </a:bodyPr>
+          <a:lstStyle/>
+          <a:p>
+            <a:r>
+              <a:rPr sz="1300" b="0" i="0">
+                <a:solidFill>
+                  <a:srgbClr val="6E6E6E"/>
+                </a:solidFill>
+                <a:latin typeface="Inter"/>
+              </a:rPr>
+              <a:t>reintegro que ofrece MODO en sucursales</a:t>
+            </a:r>
+          </a:p>
+          <a:p>
+            <a:r>
+              <a:rPr sz="1300" b="0" i="0">
+                <a:solidFill>
+                  <a:srgbClr val="6E6E6E"/>
+                </a:solidFill>
+                <a:latin typeface="Inter"/>
+              </a:rPr>
+              <a:t>COTO desde may. 2024 — acumulable con</a:t>
+            </a:r>
+          </a:p>
+          <a:p>
+            <a:r>
+              <a:rPr sz="1300" b="0" i="0">
+                <a:solidFill>
+                  <a:srgbClr val="6E6E6E"/>
+                </a:solidFill>
+                <a:latin typeface="Inter"/>
+              </a:rPr>
+              <a:t>ofertas propias de COTO</a:t>
+            </a:r>
+          </a:p>
+        </p:txBody>
+      </p:sp>
+      <p:sp>
+        <p:nvSpPr>
+          <p:cNvPr id="7" name="TextBox 6"/>
+          <p:cNvSpPr txBox="1"/>
+          <p:nvPr/>
+        </p:nvSpPr>
+        <p:spPr>
+          <a:xfrm>
+            <a:off x="4572000" y="1874519"/>
+            <a:ext cx="6858000" cy="3017520"/>
           </a:xfrm>
           <a:prstGeom prst="rect">
             <a:avLst/>
@@ -7391,14 +7925,14 @@
       </p:sp>
       <p:sp>
         <p:nvSpPr>
-          <p:cNvPr id="6" name="Rounded Rectangle 5"/>
+          <p:cNvPr id="8" name="Rounded Rectangle 7"/>
           <p:cNvSpPr/>
           <p:nvPr/>
         </p:nvSpPr>
         <p:spPr>
           <a:xfrm>
-            <a:off x="548640" y="5074920"/>
-            <a:ext cx="10881360" cy="502920"/>
+            <a:off x="548640" y="5072888"/>
+            <a:ext cx="10881360" cy="594360"/>
           </a:xfrm>
           <a:prstGeom prst="roundRect">
             <a:avLst>
@@ -7446,7 +7980,7 @@
       </p:sp>
       <p:sp>
         <p:nvSpPr>
-          <p:cNvPr id="7" name="TextBox 6"/>
+          <p:cNvPr id="9" name="TextBox 8"/>
           <p:cNvSpPr txBox="1"/>
           <p:nvPr/>
         </p:nvSpPr>
@@ -7480,7 +8014,7 @@
       </p:sp>
       <p:sp>
         <p:nvSpPr>
-          <p:cNvPr id="8" name="TextBox 7"/>
+          <p:cNvPr id="10" name="TextBox 9"/>
           <p:cNvSpPr txBox="1"/>
           <p:nvPr/>
         </p:nvSpPr>
@@ -7651,7 +8185,7 @@
         <p:spPr>
           <a:xfrm>
             <a:off x="548640" y="2103120"/>
-            <a:ext cx="10881360" cy="3017520"/>
+            <a:ext cx="10881360" cy="1828800"/>
           </a:xfrm>
           <a:prstGeom prst="rect">
             <a:avLst/>
@@ -7738,56 +8272,6 @@
               <a:t>Diferenciadores clave:</a:t>
             </a:r>
           </a:p>
-          <a:p>
-            <a:pPr lvl="1">
-              <a:spcAft>
-                <a:spcPts val="1000"/>
-              </a:spcAft>
-            </a:pPr>
-            <a:r>
-              <a:rPr sz="1350" b="1" i="0">
-                <a:solidFill>
-                  <a:srgbClr val="502BD8"/>
-                </a:solidFill>
-                <a:latin typeface="Inter"/>
-              </a:rPr>
-              <a:t>-  </a:t>
-            </a:r>
-            <a:r>
-              <a:rPr sz="1350" b="0" i="0">
-                <a:solidFill>
-                  <a:srgbClr val="222222"/>
-                </a:solidFill>
-                <a:latin typeface="Inter"/>
-              </a:rPr>
-              <a:t>Beneficios personalizados por historial real (no % genérico por rubro)</a:t>
-            </a:r>
-          </a:p>
-          <a:p>
-            <a:pPr lvl="1">
-              <a:spcAft>
-                <a:spcPts val="1000"/>
-              </a:spcAft>
-            </a:pPr>
-            <a:r>
-              <a:rPr sz="1350" b="1" i="0">
-                <a:solidFill>
-                  <a:srgbClr val="502BD8"/>
-                </a:solidFill>
-                <a:latin typeface="Inter"/>
-              </a:rPr>
-              <a:t>-  </a:t>
-            </a:r>
-            <a:r>
-              <a:rPr sz="1350" b="0" i="0">
-                <a:solidFill>
-                  <a:srgbClr val="222222"/>
-                </a:solidFill>
-                <a:latin typeface="Inter"/>
-              </a:rPr>
-              <a:t>Fidelización dentro del mismo instrumento de pago, sin tarjeta aparte</a:t>
-            </a:r>
-          </a:p>
         </p:txBody>
       </p:sp>
       <p:sp>
@@ -7798,8 +8282,278 @@
         </p:nvSpPr>
         <p:spPr>
           <a:xfrm>
-            <a:off x="548640" y="5349240"/>
-            <a:ext cx="10881360" cy="822960"/>
+            <a:off x="548640" y="3812032"/>
+            <a:ext cx="5303520" cy="1234440"/>
+          </a:xfrm>
+          <a:prstGeom prst="roundRect">
+            <a:avLst>
+              <a:gd name="adj" fmla="val 6000"/>
+            </a:avLst>
+          </a:prstGeom>
+          <a:solidFill>
+            <a:srgbClr val="FFFFFF"/>
+          </a:solidFill>
+          <a:ln>
+            <a:noFill/>
+          </a:ln>
+          <a:effectLst/>
+        </p:spPr>
+        <p:style>
+          <a:lnRef idx="1">
+            <a:schemeClr val="accent1"/>
+          </a:lnRef>
+          <a:fillRef idx="3">
+            <a:schemeClr val="accent1"/>
+          </a:fillRef>
+          <a:effectRef idx="2">
+            <a:schemeClr val="accent1"/>
+          </a:effectRef>
+          <a:fontRef idx="minor">
+            <a:schemeClr val="lt1"/>
+          </a:fontRef>
+        </p:style>
+        <p:txBody>
+          <a:bodyPr rtlCol="0" anchor="ctr"/>
+          <a:lstStyle/>
+          <a:p>
+            <a:pPr algn="ctr"/>
+          </a:p>
+        </p:txBody>
+      </p:sp>
+      <p:sp>
+        <p:nvSpPr>
+          <p:cNvPr id="7" name="Rounded Rectangle 6"/>
+          <p:cNvSpPr/>
+          <p:nvPr/>
+        </p:nvSpPr>
+        <p:spPr>
+          <a:xfrm>
+            <a:off x="777240" y="4040632"/>
+            <a:ext cx="2926080" cy="347472"/>
+          </a:xfrm>
+          <a:prstGeom prst="roundRect">
+            <a:avLst>
+              <a:gd name="adj" fmla="val 50000"/>
+            </a:avLst>
+          </a:prstGeom>
+          <a:solidFill>
+            <a:srgbClr val="502BD8"/>
+          </a:solidFill>
+          <a:ln>
+            <a:noFill/>
+          </a:ln>
+          <a:effectLst/>
+        </p:spPr>
+        <p:style>
+          <a:lnRef idx="1">
+            <a:schemeClr val="accent1"/>
+          </a:lnRef>
+          <a:fillRef idx="3">
+            <a:schemeClr val="accent1"/>
+          </a:fillRef>
+          <a:effectRef idx="2">
+            <a:schemeClr val="accent1"/>
+          </a:effectRef>
+          <a:fontRef idx="minor">
+            <a:schemeClr val="lt1"/>
+          </a:fontRef>
+        </p:style>
+        <p:txBody>
+          <a:bodyPr rtlCol="0" anchor="ctr" wrap="square" lIns="73152" rIns="73152"/>
+          <a:lstStyle/>
+          <a:p>
+            <a:pPr algn="ctr"/>
+            <a:r>
+              <a:rPr sz="1100" b="1" i="0">
+                <a:solidFill>
+                  <a:srgbClr val="FFFFFF"/>
+                </a:solidFill>
+                <a:latin typeface="Inter"/>
+              </a:rPr>
+              <a:t>Beneficios personalizados</a:t>
+            </a:r>
+          </a:p>
+        </p:txBody>
+      </p:sp>
+      <p:sp>
+        <p:nvSpPr>
+          <p:cNvPr id="8" name="TextBox 7"/>
+          <p:cNvSpPr txBox="1"/>
+          <p:nvPr/>
+        </p:nvSpPr>
+        <p:spPr>
+          <a:xfrm>
+            <a:off x="777240" y="4525264"/>
+            <a:ext cx="4846320" cy="338328"/>
+          </a:xfrm>
+          <a:prstGeom prst="rect">
+            <a:avLst/>
+          </a:prstGeom>
+          <a:noFill/>
+        </p:spPr>
+        <p:txBody>
+          <a:bodyPr wrap="square">
+            <a:spAutoFit/>
+          </a:bodyPr>
+          <a:lstStyle/>
+          <a:p>
+            <a:r>
+              <a:rPr sz="1300" b="0" i="0">
+                <a:solidFill>
+                  <a:srgbClr val="222222"/>
+                </a:solidFill>
+                <a:latin typeface="Inter"/>
+              </a:rPr>
+              <a:t>Por historial real de compra — no un % genérico por rubro, como Cuenta DNI.</a:t>
+            </a:r>
+          </a:p>
+        </p:txBody>
+      </p:sp>
+      <p:sp>
+        <p:nvSpPr>
+          <p:cNvPr id="9" name="Rounded Rectangle 8"/>
+          <p:cNvSpPr/>
+          <p:nvPr/>
+        </p:nvSpPr>
+        <p:spPr>
+          <a:xfrm>
+            <a:off x="6126479" y="3812032"/>
+            <a:ext cx="5303520" cy="1234440"/>
+          </a:xfrm>
+          <a:prstGeom prst="roundRect">
+            <a:avLst>
+              <a:gd name="adj" fmla="val 6000"/>
+            </a:avLst>
+          </a:prstGeom>
+          <a:solidFill>
+            <a:srgbClr val="FFFFFF"/>
+          </a:solidFill>
+          <a:ln>
+            <a:noFill/>
+          </a:ln>
+          <a:effectLst/>
+        </p:spPr>
+        <p:style>
+          <a:lnRef idx="1">
+            <a:schemeClr val="accent1"/>
+          </a:lnRef>
+          <a:fillRef idx="3">
+            <a:schemeClr val="accent1"/>
+          </a:fillRef>
+          <a:effectRef idx="2">
+            <a:schemeClr val="accent1"/>
+          </a:effectRef>
+          <a:fontRef idx="minor">
+            <a:schemeClr val="lt1"/>
+          </a:fontRef>
+        </p:style>
+        <p:txBody>
+          <a:bodyPr rtlCol="0" anchor="ctr"/>
+          <a:lstStyle/>
+          <a:p>
+            <a:pPr algn="ctr"/>
+          </a:p>
+        </p:txBody>
+      </p:sp>
+      <p:sp>
+        <p:nvSpPr>
+          <p:cNvPr id="10" name="Rounded Rectangle 9"/>
+          <p:cNvSpPr/>
+          <p:nvPr/>
+        </p:nvSpPr>
+        <p:spPr>
+          <a:xfrm>
+            <a:off x="6355079" y="4040632"/>
+            <a:ext cx="2926080" cy="347472"/>
+          </a:xfrm>
+          <a:prstGeom prst="roundRect">
+            <a:avLst>
+              <a:gd name="adj" fmla="val 50000"/>
+            </a:avLst>
+          </a:prstGeom>
+          <a:solidFill>
+            <a:srgbClr val="502BD8"/>
+          </a:solidFill>
+          <a:ln>
+            <a:noFill/>
+          </a:ln>
+          <a:effectLst/>
+        </p:spPr>
+        <p:style>
+          <a:lnRef idx="1">
+            <a:schemeClr val="accent1"/>
+          </a:lnRef>
+          <a:fillRef idx="3">
+            <a:schemeClr val="accent1"/>
+          </a:fillRef>
+          <a:effectRef idx="2">
+            <a:schemeClr val="accent1"/>
+          </a:effectRef>
+          <a:fontRef idx="minor">
+            <a:schemeClr val="lt1"/>
+          </a:fontRef>
+        </p:style>
+        <p:txBody>
+          <a:bodyPr rtlCol="0" anchor="ctr" wrap="square" lIns="73152" rIns="73152"/>
+          <a:lstStyle/>
+          <a:p>
+            <a:pPr algn="ctr"/>
+            <a:r>
+              <a:rPr sz="1100" b="1" i="0">
+                <a:solidFill>
+                  <a:srgbClr val="FFFFFF"/>
+                </a:solidFill>
+                <a:latin typeface="Inter"/>
+              </a:rPr>
+              <a:t>Fidelización integrada</a:t>
+            </a:r>
+          </a:p>
+        </p:txBody>
+      </p:sp>
+      <p:sp>
+        <p:nvSpPr>
+          <p:cNvPr id="11" name="TextBox 10"/>
+          <p:cNvSpPr txBox="1"/>
+          <p:nvPr/>
+        </p:nvSpPr>
+        <p:spPr>
+          <a:xfrm>
+            <a:off x="6355079" y="4525264"/>
+            <a:ext cx="4846320" cy="338328"/>
+          </a:xfrm>
+          <a:prstGeom prst="rect">
+            <a:avLst/>
+          </a:prstGeom>
+          <a:noFill/>
+        </p:spPr>
+        <p:txBody>
+          <a:bodyPr wrap="square">
+            <a:spAutoFit/>
+          </a:bodyPr>
+          <a:lstStyle/>
+          <a:p>
+            <a:r>
+              <a:rPr sz="1300" b="0" i="0">
+                <a:solidFill>
+                  <a:srgbClr val="222222"/>
+                </a:solidFill>
+                <a:latin typeface="Inter"/>
+              </a:rPr>
+              <a:t>Dentro del mismo instrumento de pago, sin tarjeta aparte.</a:t>
+            </a:r>
+          </a:p>
+        </p:txBody>
+      </p:sp>
+      <p:sp>
+        <p:nvSpPr>
+          <p:cNvPr id="12" name="Rounded Rectangle 11"/>
+          <p:cNvSpPr/>
+          <p:nvPr/>
+        </p:nvSpPr>
+        <p:spPr>
+          <a:xfrm>
+            <a:off x="548640" y="5320791"/>
+            <a:ext cx="10881360" cy="777240"/>
           </a:xfrm>
           <a:prstGeom prst="roundRect">
             <a:avLst>
@@ -7847,7 +8601,7 @@
       </p:sp>
       <p:sp>
         <p:nvSpPr>
-          <p:cNvPr id="7" name="TextBox 6"/>
+          <p:cNvPr id="13" name="TextBox 12"/>
           <p:cNvSpPr txBox="1"/>
           <p:nvPr/>
         </p:nvSpPr>
@@ -7881,7 +8635,7 @@
       </p:sp>
       <p:sp>
         <p:nvSpPr>
-          <p:cNvPr id="8" name="TextBox 7"/>
+          <p:cNvPr id="14" name="TextBox 13"/>
           <p:cNvSpPr txBox="1"/>
           <p:nvPr/>
         </p:nvSpPr>
@@ -9363,8 +10117,173 @@
         </p:nvSpPr>
         <p:spPr>
           <a:xfrm>
-            <a:off x="548640" y="5532120"/>
-            <a:ext cx="10881360" cy="822960"/>
+            <a:off x="548640" y="4765040"/>
+            <a:ext cx="1636776" cy="411480"/>
+          </a:xfrm>
+          <a:prstGeom prst="roundRect">
+            <a:avLst>
+              <a:gd name="adj" fmla="val 50000"/>
+            </a:avLst>
+          </a:prstGeom>
+          <a:solidFill>
+            <a:srgbClr val="EDEDED"/>
+          </a:solidFill>
+          <a:ln>
+            <a:noFill/>
+          </a:ln>
+          <a:effectLst/>
+        </p:spPr>
+        <p:style>
+          <a:lnRef idx="1">
+            <a:schemeClr val="accent1"/>
+          </a:lnRef>
+          <a:fillRef idx="3">
+            <a:schemeClr val="accent1"/>
+          </a:fillRef>
+          <a:effectRef idx="2">
+            <a:schemeClr val="accent1"/>
+          </a:effectRef>
+          <a:fontRef idx="minor">
+            <a:schemeClr val="lt1"/>
+          </a:fontRef>
+        </p:style>
+        <p:txBody>
+          <a:bodyPr rtlCol="0" anchor="ctr" wrap="square" lIns="73152" rIns="73152"/>
+          <a:lstStyle/>
+          <a:p>
+            <a:pPr algn="ctr"/>
+            <a:r>
+              <a:rPr sz="1200" b="0" i="0">
+                <a:solidFill>
+                  <a:srgbClr val="6E6E6E"/>
+                </a:solidFill>
+                <a:latin typeface="Inter"/>
+              </a:rPr>
+              <a:t>Brand</a:t>
+            </a:r>
+          </a:p>
+        </p:txBody>
+      </p:sp>
+      <p:sp>
+        <p:nvSpPr>
+          <p:cNvPr id="8" name="Rounded Rectangle 7"/>
+          <p:cNvSpPr/>
+          <p:nvPr/>
+        </p:nvSpPr>
+        <p:spPr>
+          <a:xfrm>
+            <a:off x="2295144" y="4765040"/>
+            <a:ext cx="1636776" cy="411480"/>
+          </a:xfrm>
+          <a:prstGeom prst="roundRect">
+            <a:avLst>
+              <a:gd name="adj" fmla="val 50000"/>
+            </a:avLst>
+          </a:prstGeom>
+          <a:solidFill>
+            <a:srgbClr val="EDEDED"/>
+          </a:solidFill>
+          <a:ln>
+            <a:noFill/>
+          </a:ln>
+          <a:effectLst/>
+        </p:spPr>
+        <p:style>
+          <a:lnRef idx="1">
+            <a:schemeClr val="accent1"/>
+          </a:lnRef>
+          <a:fillRef idx="3">
+            <a:schemeClr val="accent1"/>
+          </a:fillRef>
+          <a:effectRef idx="2">
+            <a:schemeClr val="accent1"/>
+          </a:effectRef>
+          <a:fontRef idx="minor">
+            <a:schemeClr val="lt1"/>
+          </a:fontRef>
+        </p:style>
+        <p:txBody>
+          <a:bodyPr rtlCol="0" anchor="ctr" wrap="square" lIns="73152" rIns="73152"/>
+          <a:lstStyle/>
+          <a:p>
+            <a:pPr algn="ctr"/>
+            <a:r>
+              <a:rPr sz="1200" b="0" i="0">
+                <a:solidFill>
+                  <a:srgbClr val="6E6E6E"/>
+                </a:solidFill>
+                <a:latin typeface="Inter"/>
+              </a:rPr>
+              <a:t>Embedding</a:t>
+            </a:r>
+          </a:p>
+        </p:txBody>
+      </p:sp>
+      <p:sp>
+        <p:nvSpPr>
+          <p:cNvPr id="9" name="Rounded Rectangle 8"/>
+          <p:cNvSpPr/>
+          <p:nvPr/>
+        </p:nvSpPr>
+        <p:spPr>
+          <a:xfrm>
+            <a:off x="4041648" y="4765040"/>
+            <a:ext cx="1636776" cy="411480"/>
+          </a:xfrm>
+          <a:prstGeom prst="roundRect">
+            <a:avLst>
+              <a:gd name="adj" fmla="val 50000"/>
+            </a:avLst>
+          </a:prstGeom>
+          <a:solidFill>
+            <a:srgbClr val="EDEDED"/>
+          </a:solidFill>
+          <a:ln>
+            <a:noFill/>
+          </a:ln>
+          <a:effectLst/>
+        </p:spPr>
+        <p:style>
+          <a:lnRef idx="1">
+            <a:schemeClr val="accent1"/>
+          </a:lnRef>
+          <a:fillRef idx="3">
+            <a:schemeClr val="accent1"/>
+          </a:fillRef>
+          <a:effectRef idx="2">
+            <a:schemeClr val="accent1"/>
+          </a:effectRef>
+          <a:fontRef idx="minor">
+            <a:schemeClr val="lt1"/>
+          </a:fontRef>
+        </p:style>
+        <p:txBody>
+          <a:bodyPr rtlCol="0" anchor="ctr" wrap="square" lIns="73152" rIns="73152"/>
+          <a:lstStyle/>
+          <a:p>
+            <a:pPr algn="ctr"/>
+            <a:r>
+              <a:rPr sz="1200" b="0" i="0">
+                <a:solidFill>
+                  <a:srgbClr val="6E6E6E"/>
+                </a:solidFill>
+                <a:latin typeface="Inter"/>
+              </a:rPr>
+              <a:t>Escala</a:t>
+            </a:r>
+          </a:p>
+        </p:txBody>
+      </p:sp>
+      <p:sp>
+        <p:nvSpPr>
+          <p:cNvPr id="10" name="Rounded Rectangle 9"/>
+          <p:cNvSpPr/>
+          <p:nvPr/>
+        </p:nvSpPr>
+        <p:spPr>
+          <a:xfrm>
+            <a:off x="548640" y="5450840"/>
+            <a:ext cx="10881360" cy="777240"/>
           </a:xfrm>
           <a:prstGeom prst="roundRect">
             <a:avLst>
@@ -9412,7 +10331,7 @@
       </p:sp>
       <p:sp>
         <p:nvSpPr>
-          <p:cNvPr id="8" name="TextBox 7"/>
+          <p:cNvPr id="11" name="TextBox 10"/>
           <p:cNvSpPr txBox="1"/>
           <p:nvPr/>
         </p:nvSpPr>
@@ -9446,7 +10365,7 @@
       </p:sp>
       <p:sp>
         <p:nvSpPr>
-          <p:cNvPr id="9" name="TextBox 8"/>
+          <p:cNvPr id="12" name="TextBox 11"/>
           <p:cNvSpPr txBox="1"/>
           <p:nvPr/>
         </p:nvSpPr>
@@ -9671,7 +10590,7 @@
           <a:noFill/>
         </p:spPr>
         <p:txBody>
-          <a:bodyPr wrap="square">
+          <a:bodyPr wrap="none">
             <a:spAutoFit/>
           </a:bodyPr>
           <a:lstStyle/>
@@ -9697,7 +10616,7 @@
         <p:spPr>
           <a:xfrm>
             <a:off x="868680" y="2587752"/>
-            <a:ext cx="4663440" cy="457200"/>
+            <a:ext cx="4663440" cy="380847"/>
           </a:xfrm>
           <a:prstGeom prst="rect">
             <a:avLst/>
@@ -9785,7 +10704,7 @@
           <a:noFill/>
         </p:spPr>
         <p:txBody>
-          <a:bodyPr wrap="square">
+          <a:bodyPr wrap="none">
             <a:spAutoFit/>
           </a:bodyPr>
           <a:lstStyle/>
@@ -9811,7 +10730,7 @@
         <p:spPr>
           <a:xfrm>
             <a:off x="6492240" y="2587752"/>
-            <a:ext cx="4663440" cy="457200"/>
+            <a:ext cx="4663440" cy="380847"/>
           </a:xfrm>
           <a:prstGeom prst="rect">
             <a:avLst/>
@@ -10671,14 +11590,94 @@
       </p:sp>
       <p:sp>
         <p:nvSpPr>
-          <p:cNvPr id="5" name="TextBox 4"/>
+          <p:cNvPr id="5" name="Rounded Rectangle 4"/>
+          <p:cNvSpPr/>
+          <p:nvPr/>
+        </p:nvSpPr>
+        <p:spPr>
+          <a:xfrm>
+            <a:off x="548640" y="2103120"/>
+            <a:ext cx="2514600" cy="1737360"/>
+          </a:xfrm>
+          <a:prstGeom prst="roundRect">
+            <a:avLst>
+              <a:gd name="adj" fmla="val 6000"/>
+            </a:avLst>
+          </a:prstGeom>
+          <a:solidFill>
+            <a:srgbClr val="FFFFFF"/>
+          </a:solidFill>
+          <a:ln>
+            <a:noFill/>
+          </a:ln>
+          <a:effectLst/>
+        </p:spPr>
+        <p:style>
+          <a:lnRef idx="1">
+            <a:schemeClr val="accent1"/>
+          </a:lnRef>
+          <a:fillRef idx="3">
+            <a:schemeClr val="accent1"/>
+          </a:fillRef>
+          <a:effectRef idx="2">
+            <a:schemeClr val="accent1"/>
+          </a:effectRef>
+          <a:fontRef idx="minor">
+            <a:schemeClr val="lt1"/>
+          </a:fontRef>
+        </p:style>
+        <p:txBody>
+          <a:bodyPr rtlCol="0" anchor="ctr"/>
+          <a:lstStyle/>
+          <a:p>
+            <a:pPr algn="ctr"/>
+          </a:p>
+        </p:txBody>
+      </p:sp>
+      <p:sp>
+        <p:nvSpPr>
+          <p:cNvPr id="6" name="TextBox 5"/>
           <p:cNvSpPr txBox="1"/>
           <p:nvPr/>
         </p:nvSpPr>
         <p:spPr>
           <a:xfrm>
-            <a:off x="548640" y="2103120"/>
-            <a:ext cx="2514600" cy="1188720"/>
+            <a:off x="868680" y="2377439"/>
+            <a:ext cx="1920240" cy="457200"/>
+          </a:xfrm>
+          <a:prstGeom prst="rect">
+            <a:avLst/>
+          </a:prstGeom>
+          <a:noFill/>
+        </p:spPr>
+        <p:txBody>
+          <a:bodyPr wrap="none">
+            <a:spAutoFit/>
+          </a:bodyPr>
+          <a:lstStyle/>
+          <a:p>
+            <a:r>
+              <a:rPr sz="2400" b="1" i="0">
+                <a:solidFill>
+                  <a:srgbClr val="502BD8"/>
+                </a:solidFill>
+                <a:latin typeface="Inter"/>
+              </a:rPr>
+              <a:t>+45,8%</a:t>
+            </a:r>
+          </a:p>
+        </p:txBody>
+      </p:sp>
+      <p:sp>
+        <p:nvSpPr>
+          <p:cNvPr id="7" name="TextBox 6"/>
+          <p:cNvSpPr txBox="1"/>
+          <p:nvPr/>
+        </p:nvSpPr>
+        <p:spPr>
+          <a:xfrm>
+            <a:off x="868680" y="2907791"/>
+            <a:ext cx="1920240" cy="624535"/>
           </a:xfrm>
           <a:prstGeom prst="rect">
             <a:avLst/>
@@ -10692,27 +11691,118 @@
           <a:lstStyle/>
           <a:p>
             <a:r>
-              <a:rPr sz="3200" b="1" i="0">
+              <a:rPr sz="1300" b="0" i="0">
+                <a:solidFill>
+                  <a:srgbClr val="6E6E6E"/>
+                </a:solidFill>
+                <a:latin typeface="Inter"/>
+              </a:rPr>
+              <a:t>QR interoperable interanual</a:t>
+            </a:r>
+          </a:p>
+          <a:p>
+            <a:r>
+              <a:rPr sz="1300" b="0" i="0">
+                <a:solidFill>
+                  <a:srgbClr val="6E6E6E"/>
+                </a:solidFill>
+                <a:latin typeface="Inter"/>
+              </a:rPr>
+              <a:t>(BCRA); débito cae 16,8%</a:t>
+            </a:r>
+          </a:p>
+        </p:txBody>
+      </p:sp>
+      <p:sp>
+        <p:nvSpPr>
+          <p:cNvPr id="8" name="Rounded Rectangle 7"/>
+          <p:cNvSpPr/>
+          <p:nvPr/>
+        </p:nvSpPr>
+        <p:spPr>
+          <a:xfrm>
+            <a:off x="3246120" y="2103120"/>
+            <a:ext cx="2514600" cy="1737360"/>
+          </a:xfrm>
+          <a:prstGeom prst="roundRect">
+            <a:avLst>
+              <a:gd name="adj" fmla="val 6000"/>
+            </a:avLst>
+          </a:prstGeom>
+          <a:solidFill>
+            <a:srgbClr val="FFFFFF"/>
+          </a:solidFill>
+          <a:ln>
+            <a:noFill/>
+          </a:ln>
+          <a:effectLst/>
+        </p:spPr>
+        <p:style>
+          <a:lnRef idx="1">
+            <a:schemeClr val="accent1"/>
+          </a:lnRef>
+          <a:fillRef idx="3">
+            <a:schemeClr val="accent1"/>
+          </a:fillRef>
+          <a:effectRef idx="2">
+            <a:schemeClr val="accent1"/>
+          </a:effectRef>
+          <a:fontRef idx="minor">
+            <a:schemeClr val="lt1"/>
+          </a:fontRef>
+        </p:style>
+        <p:txBody>
+          <a:bodyPr rtlCol="0" anchor="ctr"/>
+          <a:lstStyle/>
+          <a:p>
+            <a:pPr algn="ctr"/>
+          </a:p>
+        </p:txBody>
+      </p:sp>
+      <p:sp>
+        <p:nvSpPr>
+          <p:cNvPr id="9" name="TextBox 8"/>
+          <p:cNvSpPr txBox="1"/>
+          <p:nvPr/>
+        </p:nvSpPr>
+        <p:spPr>
+          <a:xfrm>
+            <a:off x="3566160" y="2377439"/>
+            <a:ext cx="1920240" cy="457200"/>
+          </a:xfrm>
+          <a:prstGeom prst="rect">
+            <a:avLst/>
+          </a:prstGeom>
+          <a:noFill/>
+        </p:spPr>
+        <p:txBody>
+          <a:bodyPr wrap="none">
+            <a:spAutoFit/>
+          </a:bodyPr>
+          <a:lstStyle/>
+          <a:p>
+            <a:r>
+              <a:rPr sz="2400" b="1" i="0">
                 <a:solidFill>
                   <a:srgbClr val="502BD8"/>
                 </a:solidFill>
                 <a:latin typeface="Inter"/>
               </a:rPr>
-              <a:t>+45,8%</a:t>
-            </a:r>
-          </a:p>
-        </p:txBody>
-      </p:sp>
-      <p:sp>
-        <p:nvSpPr>
-          <p:cNvPr id="6" name="TextBox 5"/>
+              <a:t>34%→43%</a:t>
+            </a:r>
+          </a:p>
+        </p:txBody>
+      </p:sp>
+      <p:sp>
+        <p:nvSpPr>
+          <p:cNvPr id="10" name="TextBox 9"/>
           <p:cNvSpPr txBox="1"/>
           <p:nvPr/>
         </p:nvSpPr>
         <p:spPr>
           <a:xfrm>
-            <a:off x="594360" y="3154679"/>
-            <a:ext cx="2423160" cy="822960"/>
+            <a:off x="3566160" y="2907791"/>
+            <a:ext cx="1920240" cy="624535"/>
           </a:xfrm>
           <a:prstGeom prst="rect">
             <a:avLst/>
@@ -10726,38 +11816,118 @@
           <a:lstStyle/>
           <a:p>
             <a:r>
-              <a:rPr sz="1200" b="0" i="0">
+              <a:rPr sz="1300" b="0" i="0">
                 <a:solidFill>
                   <a:srgbClr val="6E6E6E"/>
                 </a:solidFill>
                 <a:latin typeface="Inter"/>
               </a:rPr>
-              <a:t>QR interoperable interanual</a:t>
-            </a:r>
-          </a:p>
-          <a:p>
-            <a:r>
-              <a:rPr sz="1200" b="0" i="0">
+              <a:t>del valor pagado en comercio físico</a:t>
+            </a:r>
+          </a:p>
+          <a:p>
+            <a:r>
+              <a:rPr sz="1300" b="0" i="0">
                 <a:solidFill>
                   <a:srgbClr val="6E6E6E"/>
                 </a:solidFill>
                 <a:latin typeface="Inter"/>
               </a:rPr>
-              <a:t>(BCRA); débito cae 16,8%</a:t>
-            </a:r>
-          </a:p>
-        </p:txBody>
-      </p:sp>
-      <p:sp>
-        <p:nvSpPr>
-          <p:cNvPr id="7" name="TextBox 6"/>
+              <a:t>con billeteras (Global Payments '26)</a:t>
+            </a:r>
+          </a:p>
+        </p:txBody>
+      </p:sp>
+      <p:sp>
+        <p:nvSpPr>
+          <p:cNvPr id="11" name="Rounded Rectangle 10"/>
+          <p:cNvSpPr/>
+          <p:nvPr/>
+        </p:nvSpPr>
+        <p:spPr>
+          <a:xfrm>
+            <a:off x="5943600" y="2103120"/>
+            <a:ext cx="2514600" cy="1737360"/>
+          </a:xfrm>
+          <a:prstGeom prst="roundRect">
+            <a:avLst>
+              <a:gd name="adj" fmla="val 6000"/>
+            </a:avLst>
+          </a:prstGeom>
+          <a:solidFill>
+            <a:srgbClr val="FFFFFF"/>
+          </a:solidFill>
+          <a:ln>
+            <a:noFill/>
+          </a:ln>
+          <a:effectLst/>
+        </p:spPr>
+        <p:style>
+          <a:lnRef idx="1">
+            <a:schemeClr val="accent1"/>
+          </a:lnRef>
+          <a:fillRef idx="3">
+            <a:schemeClr val="accent1"/>
+          </a:fillRef>
+          <a:effectRef idx="2">
+            <a:schemeClr val="accent1"/>
+          </a:effectRef>
+          <a:fontRef idx="minor">
+            <a:schemeClr val="lt1"/>
+          </a:fontRef>
+        </p:style>
+        <p:txBody>
+          <a:bodyPr rtlCol="0" anchor="ctr"/>
+          <a:lstStyle/>
+          <a:p>
+            <a:pPr algn="ctr"/>
+          </a:p>
+        </p:txBody>
+      </p:sp>
+      <p:sp>
+        <p:nvSpPr>
+          <p:cNvPr id="12" name="TextBox 11"/>
           <p:cNvSpPr txBox="1"/>
           <p:nvPr/>
         </p:nvSpPr>
         <p:spPr>
           <a:xfrm>
-            <a:off x="3246120" y="2103120"/>
-            <a:ext cx="2514600" cy="1188720"/>
+            <a:off x="6263640" y="2377439"/>
+            <a:ext cx="1920240" cy="457200"/>
+          </a:xfrm>
+          <a:prstGeom prst="rect">
+            <a:avLst/>
+          </a:prstGeom>
+          <a:noFill/>
+        </p:spPr>
+        <p:txBody>
+          <a:bodyPr wrap="none">
+            <a:spAutoFit/>
+          </a:bodyPr>
+          <a:lstStyle/>
+          <a:p>
+            <a:r>
+              <a:rPr sz="2400" b="1" i="0">
+                <a:solidFill>
+                  <a:srgbClr val="502BD8"/>
+                </a:solidFill>
+                <a:latin typeface="Inter"/>
+              </a:rPr>
+              <a:t>84%</a:t>
+            </a:r>
+          </a:p>
+        </p:txBody>
+      </p:sp>
+      <p:sp>
+        <p:nvSpPr>
+          <p:cNvPr id="13" name="TextBox 12"/>
+          <p:cNvSpPr txBox="1"/>
+          <p:nvPr/>
+        </p:nvSpPr>
+        <p:spPr>
+          <a:xfrm>
+            <a:off x="6263640" y="2907791"/>
+            <a:ext cx="1920240" cy="624535"/>
           </a:xfrm>
           <a:prstGeom prst="rect">
             <a:avLst/>
@@ -10771,27 +11941,118 @@
           <a:lstStyle/>
           <a:p>
             <a:r>
-              <a:rPr sz="3200" b="1" i="0">
+              <a:rPr sz="1300" b="0" i="0">
+                <a:solidFill>
+                  <a:srgbClr val="6E6E6E"/>
+                </a:solidFill>
+                <a:latin typeface="Inter"/>
+              </a:rPr>
+              <a:t>de argentinos usa QR para pagar —</a:t>
+            </a:r>
+          </a:p>
+          <a:p>
+            <a:r>
+              <a:rPr sz="1300" b="0" i="0">
+                <a:solidFill>
+                  <a:srgbClr val="6E6E6E"/>
+                </a:solidFill>
+                <a:latin typeface="Inter"/>
+              </a:rPr>
+              <a:t>el más alto de LatAm</a:t>
+            </a:r>
+          </a:p>
+        </p:txBody>
+      </p:sp>
+      <p:sp>
+        <p:nvSpPr>
+          <p:cNvPr id="14" name="Rounded Rectangle 13"/>
+          <p:cNvSpPr/>
+          <p:nvPr/>
+        </p:nvSpPr>
+        <p:spPr>
+          <a:xfrm>
+            <a:off x="8641080" y="2103120"/>
+            <a:ext cx="2514600" cy="1737360"/>
+          </a:xfrm>
+          <a:prstGeom prst="roundRect">
+            <a:avLst>
+              <a:gd name="adj" fmla="val 6000"/>
+            </a:avLst>
+          </a:prstGeom>
+          <a:solidFill>
+            <a:srgbClr val="FFFFFF"/>
+          </a:solidFill>
+          <a:ln>
+            <a:noFill/>
+          </a:ln>
+          <a:effectLst/>
+        </p:spPr>
+        <p:style>
+          <a:lnRef idx="1">
+            <a:schemeClr val="accent1"/>
+          </a:lnRef>
+          <a:fillRef idx="3">
+            <a:schemeClr val="accent1"/>
+          </a:fillRef>
+          <a:effectRef idx="2">
+            <a:schemeClr val="accent1"/>
+          </a:effectRef>
+          <a:fontRef idx="minor">
+            <a:schemeClr val="lt1"/>
+          </a:fontRef>
+        </p:style>
+        <p:txBody>
+          <a:bodyPr rtlCol="0" anchor="ctr"/>
+          <a:lstStyle/>
+          <a:p>
+            <a:pPr algn="ctr"/>
+          </a:p>
+        </p:txBody>
+      </p:sp>
+      <p:sp>
+        <p:nvSpPr>
+          <p:cNvPr id="15" name="TextBox 14"/>
+          <p:cNvSpPr txBox="1"/>
+          <p:nvPr/>
+        </p:nvSpPr>
+        <p:spPr>
+          <a:xfrm>
+            <a:off x="8961119" y="2377439"/>
+            <a:ext cx="1920240" cy="457200"/>
+          </a:xfrm>
+          <a:prstGeom prst="rect">
+            <a:avLst/>
+          </a:prstGeom>
+          <a:noFill/>
+        </p:spPr>
+        <p:txBody>
+          <a:bodyPr wrap="none">
+            <a:spAutoFit/>
+          </a:bodyPr>
+          <a:lstStyle/>
+          <a:p>
+            <a:r>
+              <a:rPr sz="2400" b="1" i="0">
                 <a:solidFill>
                   <a:srgbClr val="502BD8"/>
                 </a:solidFill>
                 <a:latin typeface="Inter"/>
               </a:rPr>
-              <a:t>34%→43%</a:t>
-            </a:r>
-          </a:p>
-        </p:txBody>
-      </p:sp>
-      <p:sp>
-        <p:nvSpPr>
-          <p:cNvPr id="8" name="TextBox 7"/>
+              <a:t>11,1%</a:t>
+            </a:r>
+          </a:p>
+        </p:txBody>
+      </p:sp>
+      <p:sp>
+        <p:nvSpPr>
+          <p:cNvPr id="16" name="TextBox 15"/>
           <p:cNvSpPr txBox="1"/>
           <p:nvPr/>
         </p:nvSpPr>
         <p:spPr>
           <a:xfrm>
-            <a:off x="3291840" y="3154679"/>
-            <a:ext cx="2423160" cy="822960"/>
+            <a:off x="8961119" y="2907791"/>
+            <a:ext cx="1920240" cy="624535"/>
           </a:xfrm>
           <a:prstGeom prst="rect">
             <a:avLst/>
@@ -10805,38 +12066,93 @@
           <a:lstStyle/>
           <a:p>
             <a:r>
-              <a:rPr sz="1200" b="0" i="0">
+              <a:rPr sz="1300" b="0" i="0">
                 <a:solidFill>
                   <a:srgbClr val="6E6E6E"/>
                 </a:solidFill>
                 <a:latin typeface="Inter"/>
               </a:rPr>
-              <a:t>del valor pagado en comercio físico</a:t>
-            </a:r>
-          </a:p>
-          <a:p>
-            <a:r>
-              <a:rPr sz="1200" b="0" i="0">
+              <a:t>de ventas de supermercados ya es</a:t>
+            </a:r>
+          </a:p>
+          <a:p>
+            <a:r>
+              <a:rPr sz="1300" b="0" i="0">
                 <a:solidFill>
                   <a:srgbClr val="6E6E6E"/>
                 </a:solidFill>
                 <a:latin typeface="Inter"/>
               </a:rPr>
-              <a:t>con billeteras (Global Payments '26)</a:t>
-            </a:r>
-          </a:p>
-        </p:txBody>
-      </p:sp>
-      <p:sp>
-        <p:nvSpPr>
-          <p:cNvPr id="9" name="TextBox 8"/>
+              <a:t>“otros medios” (INDEC, nov. 2024)</a:t>
+            </a:r>
+          </a:p>
+        </p:txBody>
+      </p:sp>
+      <p:sp>
+        <p:nvSpPr>
+          <p:cNvPr id="17" name="Rounded Rectangle 16"/>
+          <p:cNvSpPr/>
+          <p:nvPr/>
+        </p:nvSpPr>
+        <p:spPr>
+          <a:xfrm>
+            <a:off x="548640" y="4160519"/>
+            <a:ext cx="10881360" cy="960120"/>
+          </a:xfrm>
+          <a:prstGeom prst="roundRect">
+            <a:avLst>
+              <a:gd name="adj" fmla="val 10000"/>
+            </a:avLst>
+          </a:prstGeom>
+          <a:solidFill>
+            <a:srgbClr val="ECE7FA"/>
+          </a:solidFill>
+          <a:ln>
+            <a:noFill/>
+          </a:ln>
+          <a:effectLst/>
+        </p:spPr>
+        <p:style>
+          <a:lnRef idx="1">
+            <a:schemeClr val="accent1"/>
+          </a:lnRef>
+          <a:fillRef idx="3">
+            <a:schemeClr val="accent1"/>
+          </a:fillRef>
+          <a:effectRef idx="2">
+            <a:schemeClr val="accent1"/>
+          </a:effectRef>
+          <a:fontRef idx="minor">
+            <a:schemeClr val="lt1"/>
+          </a:fontRef>
+        </p:style>
+        <p:txBody>
+          <a:bodyPr rtlCol="0" anchor="ctr" wrap="square" lIns="228600" rIns="228600"/>
+          <a:lstStyle/>
+          <a:p>
+            <a:pPr algn="ctr"/>
+            <a:r>
+              <a:rPr sz="1250" b="0" i="1">
+                <a:solidFill>
+                  <a:srgbClr val="222222"/>
+                </a:solidFill>
+                <a:latin typeface="Inter"/>
+              </a:rPr>
+              <a:t>Cuatro fuentes independientes (regulador, consultora de pagos, cámara de e-commerce, estadística oficial de supermercados) apuntan en la misma dirección al mismo tiempo — no es una apuesta sobre tecnología emergente, es una sustitución de medio de pago ya en curso y medible.</a:t>
+            </a:r>
+          </a:p>
+        </p:txBody>
+      </p:sp>
+      <p:sp>
+        <p:nvSpPr>
+          <p:cNvPr id="18" name="TextBox 17"/>
           <p:cNvSpPr txBox="1"/>
           <p:nvPr/>
         </p:nvSpPr>
         <p:spPr>
           <a:xfrm>
-            <a:off x="5943600" y="2103120"/>
-            <a:ext cx="2514600" cy="1188720"/>
+            <a:off x="548640" y="6510528"/>
+            <a:ext cx="8686800" cy="274320"/>
           </a:xfrm>
           <a:prstGeom prst="rect">
             <a:avLst/>
@@ -10850,170 +12166,12 @@
           <a:lstStyle/>
           <a:p>
             <a:r>
-              <a:rPr sz="3200" b="1" i="0">
-                <a:solidFill>
-                  <a:srgbClr val="502BD8"/>
-                </a:solidFill>
-                <a:latin typeface="Inter"/>
-              </a:rPr>
-              <a:t>84%</a:t>
-            </a:r>
-          </a:p>
-        </p:txBody>
-      </p:sp>
-      <p:sp>
-        <p:nvSpPr>
-          <p:cNvPr id="10" name="TextBox 9"/>
-          <p:cNvSpPr txBox="1"/>
-          <p:nvPr/>
-        </p:nvSpPr>
-        <p:spPr>
-          <a:xfrm>
-            <a:off x="5989320" y="3154679"/>
-            <a:ext cx="2423160" cy="822960"/>
-          </a:xfrm>
-          <a:prstGeom prst="rect">
-            <a:avLst/>
-          </a:prstGeom>
-          <a:noFill/>
-        </p:spPr>
-        <p:txBody>
-          <a:bodyPr wrap="square">
-            <a:spAutoFit/>
-          </a:bodyPr>
-          <a:lstStyle/>
-          <a:p>
-            <a:r>
-              <a:rPr sz="1200" b="0" i="0">
+              <a:rPr sz="900" b="0" i="0">
                 <a:solidFill>
                   <a:srgbClr val="6E6E6E"/>
                 </a:solidFill>
                 <a:latin typeface="Inter"/>
               </a:rPr>
-              <a:t>de argentinos usa QR para pagar —</a:t>
-            </a:r>
-          </a:p>
-          <a:p>
-            <a:r>
-              <a:rPr sz="1200" b="0" i="0">
-                <a:solidFill>
-                  <a:srgbClr val="6E6E6E"/>
-                </a:solidFill>
-                <a:latin typeface="Inter"/>
-              </a:rPr>
-              <a:t>el más alto de LatAm</a:t>
-            </a:r>
-          </a:p>
-        </p:txBody>
-      </p:sp>
-      <p:sp>
-        <p:nvSpPr>
-          <p:cNvPr id="11" name="TextBox 10"/>
-          <p:cNvSpPr txBox="1"/>
-          <p:nvPr/>
-        </p:nvSpPr>
-        <p:spPr>
-          <a:xfrm>
-            <a:off x="8641080" y="2103120"/>
-            <a:ext cx="2514600" cy="1188720"/>
-          </a:xfrm>
-          <a:prstGeom prst="rect">
-            <a:avLst/>
-          </a:prstGeom>
-          <a:noFill/>
-        </p:spPr>
-        <p:txBody>
-          <a:bodyPr wrap="square">
-            <a:spAutoFit/>
-          </a:bodyPr>
-          <a:lstStyle/>
-          <a:p>
-            <a:r>
-              <a:rPr sz="3200" b="1" i="0">
-                <a:solidFill>
-                  <a:srgbClr val="502BD8"/>
-                </a:solidFill>
-                <a:latin typeface="Inter"/>
-              </a:rPr>
-              <a:t>11,1%</a:t>
-            </a:r>
-          </a:p>
-        </p:txBody>
-      </p:sp>
-      <p:sp>
-        <p:nvSpPr>
-          <p:cNvPr id="12" name="TextBox 11"/>
-          <p:cNvSpPr txBox="1"/>
-          <p:nvPr/>
-        </p:nvSpPr>
-        <p:spPr>
-          <a:xfrm>
-            <a:off x="8686800" y="3154679"/>
-            <a:ext cx="2423160" cy="822960"/>
-          </a:xfrm>
-          <a:prstGeom prst="rect">
-            <a:avLst/>
-          </a:prstGeom>
-          <a:noFill/>
-        </p:spPr>
-        <p:txBody>
-          <a:bodyPr wrap="square">
-            <a:spAutoFit/>
-          </a:bodyPr>
-          <a:lstStyle/>
-          <a:p>
-            <a:r>
-              <a:rPr sz="1200" b="0" i="0">
-                <a:solidFill>
-                  <a:srgbClr val="6E6E6E"/>
-                </a:solidFill>
-                <a:latin typeface="Inter"/>
-              </a:rPr>
-              <a:t>de ventas de supermercados ya es</a:t>
-            </a:r>
-          </a:p>
-          <a:p>
-            <a:r>
-              <a:rPr sz="1200" b="0" i="0">
-                <a:solidFill>
-                  <a:srgbClr val="6E6E6E"/>
-                </a:solidFill>
-                <a:latin typeface="Inter"/>
-              </a:rPr>
-              <a:t>“otros medios” (INDEC, nov. 2024)</a:t>
-            </a:r>
-          </a:p>
-        </p:txBody>
-      </p:sp>
-      <p:sp>
-        <p:nvSpPr>
-          <p:cNvPr id="13" name="TextBox 12"/>
-          <p:cNvSpPr txBox="1"/>
-          <p:nvPr/>
-        </p:nvSpPr>
-        <p:spPr>
-          <a:xfrm>
-            <a:off x="548640" y="6510528"/>
-            <a:ext cx="8686800" cy="274320"/>
-          </a:xfrm>
-          <a:prstGeom prst="rect">
-            <a:avLst/>
-          </a:prstGeom>
-          <a:noFill/>
-        </p:spPr>
-        <p:txBody>
-          <a:bodyPr wrap="square">
-            <a:spAutoFit/>
-          </a:bodyPr>
-          <a:lstStyle/>
-          <a:p>
-            <a:r>
-              <a:rPr sz="900" b="0" i="0">
-                <a:solidFill>
-                  <a:srgbClr val="6E6E6E"/>
-                </a:solidFill>
-                <a:latin typeface="Inter"/>
-              </a:rPr>
               <a:t>Wallet COTO  ·  Por qué ahora</a:t>
             </a:r>
           </a:p>
@@ -11021,7 +12179,7 @@
       </p:sp>
       <p:sp>
         <p:nvSpPr>
-          <p:cNvPr id="14" name="TextBox 13"/>
+          <p:cNvPr id="19" name="TextBox 18"/>
           <p:cNvSpPr txBox="1"/>
           <p:nvPr/>
         </p:nvSpPr>

</xml_diff>